<commit_message>
Update Slide 1 background with the user provided split screen stadium image
</commit_message>
<xml_diff>
--- a/BPL_Presentation.pptx
+++ b/BPL_Presentation.pptx
@@ -3111,7 +3111,7 @@
       <p:grpSpPr/>
       <p:pic>
         <p:nvPicPr>
-          <p:cNvPr id="2" name="Picture 1" descr="slide1_background.png"/>
+          <p:cNvPr id="2" name="Picture 1" descr="user_split_image.jpg"/>
           <p:cNvPicPr>
             <a:picLocks noChangeAspect="1"/>
           </p:cNvPicPr>
@@ -3149,7 +3149,7 @@
           </a:prstGeom>
           <a:solidFill>
             <a:srgbClr val="0a0e1a">
-              <a:alpha val="85000"/>
+              <a:alpha val="80000"/>
             </a:srgbClr>
           </a:solidFill>
           <a:ln>

</xml_diff>